<commit_message>
Add SafeBank_Code_Walkthrough.docx and embed it in the PPTX (slide 13)
Agent-Logs-Url: https://github.com/AbishSajiNMIMS/Practice/sessions/8ce62187-a4d0-4a40-b8ef-4d584d0df906

Co-authored-by: AbishSajiNMIMS <193383655+AbishSajiNMIMS@users.noreply.github.com>
</commit_message>
<xml_diff>
--- a/SafeBank_Presentation.pptx
+++ b/SafeBank_Presentation.pptx
@@ -17,6 +17,7 @@
     <p:sldId id="265" r:id="rId16"/>
     <p:sldId id="266" r:id="rId17"/>
     <p:sldId id="267" r:id="rId18"/>
+    <p:sldId id="268" r:id="rId19"/>
   </p:sldIdLst>
   <p:sldSz cx="12188952" cy="6858000" type="screen4x3"/>
   <p:notesSz cx="6858000" cy="9144000"/>
@@ -5924,6 +5925,273 @@
 </p:sld>
 </file>
 
+<file path=ppt/slides/slide13.xml><?xml version="1.0" encoding="utf-8"?>
+<p:sld xmlns:a="http://schemas.openxmlformats.org/drawingml/2006/main" xmlns:p="http://schemas.openxmlformats.org/presentationml/2006/main" xmlns:r="http://schemas.openxmlformats.org/officeDocument/2006/relationships">
+  <p:cSld>
+    <p:bg>
+      <p:bgPr>
+        <a:solidFill>
+          <a:srgbClr val="1A1A2E"/>
+        </a:solidFill>
+        <a:effectLst/>
+      </p:bgPr>
+    </p:bg>
+    <p:spTree>
+      <p:nvGrpSpPr>
+        <p:cNvPr id="1" name=""/>
+        <p:cNvGrpSpPr/>
+        <p:nvPr/>
+      </p:nvGrpSpPr>
+      <p:grpSpPr/>
+      <p:sp>
+        <p:nvSpPr>
+          <p:cNvPr id="2" name="TextBox 1"/>
+          <p:cNvSpPr txBox="1"/>
+          <p:nvPr/>
+        </p:nvSpPr>
+        <p:spPr>
+          <a:xfrm>
+            <a:off x="457200" y="274320"/>
+            <a:ext cx="8229600" cy="914400"/>
+          </a:xfrm>
+          <a:prstGeom prst="rect">
+            <a:avLst/>
+          </a:prstGeom>
+          <a:noFill/>
+        </p:spPr>
+        <p:txBody>
+          <a:bodyPr wrap="square">
+            <a:spAutoFit/>
+          </a:bodyPr>
+          <a:lstStyle/>
+          <a:p>
+            <a:pPr algn="ctr"/>
+            <a:r>
+              <a:rPr sz="2800" b="1">
+                <a:solidFill>
+                  <a:srgbClr val="FFD700"/>
+                </a:solidFill>
+              </a:rPr>
+              <a:t>📄  Detailed Code Walkthrough Document</a:t>
+            </a:r>
+          </a:p>
+        </p:txBody>
+      </p:sp>
+      <p:sp>
+        <p:nvSpPr>
+          <p:cNvPr id="3" name="TextBox 2"/>
+          <p:cNvSpPr txBox="1"/>
+          <p:nvPr/>
+        </p:nvSpPr>
+        <p:spPr>
+          <a:xfrm>
+            <a:off x="457200" y="1097280"/>
+            <a:ext cx="8229600" cy="457200"/>
+          </a:xfrm>
+          <a:prstGeom prst="rect">
+            <a:avLst/>
+          </a:prstGeom>
+          <a:noFill/>
+        </p:spPr>
+        <p:txBody>
+          <a:bodyPr wrap="none">
+            <a:spAutoFit/>
+          </a:bodyPr>
+          <a:lstStyle/>
+          <a:p>
+            <a:pPr algn="ctr"/>
+            <a:r>
+              <a:rPr sz="1400">
+                <a:solidFill>
+                  <a:srgbClr val="CCCCFF"/>
+                </a:solidFill>
+              </a:rPr>
+              <a:t>The file  SafeBank_Code_Walkthrough.docx  is embedded in this presentation</a:t>
+            </a:r>
+          </a:p>
+        </p:txBody>
+      </p:sp>
+      <p:sp>
+        <p:nvSpPr>
+          <p:cNvPr id="4" name="TextBox 3"/>
+          <p:cNvSpPr txBox="1"/>
+          <p:nvPr/>
+        </p:nvSpPr>
+        <p:spPr>
+          <a:xfrm>
+            <a:off x="548640" y="1737360"/>
+            <a:ext cx="8046720" cy="4114800"/>
+          </a:xfrm>
+          <a:prstGeom prst="rect">
+            <a:avLst/>
+          </a:prstGeom>
+          <a:noFill/>
+        </p:spPr>
+        <p:txBody>
+          <a:bodyPr wrap="square">
+            <a:spAutoFit/>
+          </a:bodyPr>
+          <a:lstStyle/>
+          <a:p>
+            <a:r>
+              <a:rPr sz="1200" b="1">
+                <a:solidFill>
+                  <a:srgbClr val="FFFF80"/>
+                </a:solidFill>
+              </a:rPr>
+              <a:t>What's inside the Word document:</a:t>
+            </a:r>
+          </a:p>
+          <a:p>
+            <a:r>
+              <a:rPr sz="1200" b="0">
+                <a:solidFill>
+                  <a:srgbClr val="E0E0FF"/>
+                </a:solidFill>
+              </a:rPr>
+              <a:t/>
+            </a:r>
+          </a:p>
+          <a:p>
+            <a:r>
+              <a:rPr sz="1200" b="0">
+                <a:solidFill>
+                  <a:srgbClr val="E0E0FF"/>
+                </a:solidFill>
+              </a:rPr>
+              <a:t>  1.  Login Activity — OTP flow, sendOtp(), saveAndLogin()</a:t>
+            </a:r>
+          </a:p>
+          <a:p>
+            <a:r>
+              <a:rPr sz="1200" b="0">
+                <a:solidFill>
+                  <a:srgbClr val="E0E0FF"/>
+                </a:solidFill>
+              </a:rPr>
+              <a:t>  2.  DBHelper — SQLite schema (3 tables), all CRUD methods</a:t>
+            </a:r>
+          </a:p>
+          <a:p>
+            <a:r>
+              <a:rPr sz="1200" b="0">
+                <a:solidFill>
+                  <a:srgbClr val="E0E0FF"/>
+                </a:solidFill>
+              </a:rPr>
+              <a:t>  3.  Home Activity — session check, updateUI(), INR formatting</a:t>
+            </a:r>
+          </a:p>
+          <a:p>
+            <a:r>
+              <a:rPr sz="1200" b="0">
+                <a:solidFill>
+                  <a:srgbClr val="E0E0FF"/>
+                </a:solidFill>
+              </a:rPr>
+              <a:t>  4.  Account Activity — profile display, secure logout + SMS</a:t>
+            </a:r>
+          </a:p>
+          <a:p>
+            <a:r>
+              <a:rPr sz="1200" b="0">
+                <a:solidFill>
+                  <a:srgbClr val="E0E0FF"/>
+                </a:solidFill>
+              </a:rPr>
+              <a:t>  5.  Loans Activity — eligibility rules, disbursal, SMS alerts</a:t>
+            </a:r>
+          </a:p>
+          <a:p>
+            <a:r>
+              <a:rPr sz="1200" b="0">
+                <a:solidFill>
+                  <a:srgbClr val="E0E0FF"/>
+                </a:solidFill>
+              </a:rPr>
+              <a:t>  6.  Loan Calculator — EMI formula (SeekBar precision trick)</a:t>
+            </a:r>
+          </a:p>
+          <a:p>
+            <a:r>
+              <a:rPr sz="1200" b="0">
+                <a:solidFill>
+                  <a:srgbClr val="E0E0FF"/>
+                </a:solidFill>
+              </a:rPr>
+              <a:t>  7.  Fixed Deposit — create/close FD, maturity date, max-5 rule</a:t>
+            </a:r>
+          </a:p>
+          <a:p>
+            <a:r>
+              <a:rPr sz="1200" b="0">
+                <a:solidFill>
+                  <a:srgbClr val="E0E0FF"/>
+                </a:solidFill>
+              </a:rPr>
+              <a:t>  8.  Bills Activity — processPayment(), confirmation dialog</a:t>
+            </a:r>
+          </a:p>
+          <a:p>
+            <a:r>
+              <a:rPr sz="1200" b="0">
+                <a:solidFill>
+                  <a:srgbClr val="E0E0FF"/>
+                </a:solidFill>
+              </a:rPr>
+              <a:t>  9.  Cards &amp; History — colour-coded DEBIT/CREDIT transaction rows</a:t>
+            </a:r>
+          </a:p>
+          <a:p>
+            <a:r>
+              <a:rPr sz="1200" b="0">
+                <a:solidFill>
+                  <a:srgbClr val="E0E0FF"/>
+                </a:solidFill>
+              </a:rPr>
+              <a:t>  10. AndroidManifest &amp; SafeBankApp — permissions, launcher setup</a:t>
+            </a:r>
+          </a:p>
+          <a:p>
+            <a:r>
+              <a:rPr sz="1200" b="0">
+                <a:solidFill>
+                  <a:srgbClr val="E0E0FF"/>
+                </a:solidFill>
+              </a:rPr>
+              <a:t/>
+            </a:r>
+          </a:p>
+          <a:p>
+            <a:r>
+              <a:rPr sz="1200" b="0">
+                <a:solidFill>
+                  <a:srgbClr val="E0E0FF"/>
+                </a:solidFill>
+              </a:rPr>
+              <a:t>  Each section includes: purpose, step-by-step Java logic,</a:t>
+            </a:r>
+          </a:p>
+          <a:p>
+            <a:r>
+              <a:rPr sz="1200" b="0">
+                <a:solidFill>
+                  <a:srgbClr val="E0E0FF"/>
+                </a:solidFill>
+              </a:rPr>
+              <a:t>  XML layout details, code snippets, and GitHub source links.</a:t>
+            </a:r>
+          </a:p>
+        </p:txBody>
+      </p:sp>
+    </p:spTree>
+  </p:cSld>
+  <p:clrMapOvr>
+    <a:masterClrMapping/>
+  </p:clrMapOvr>
+</p:sld>
+</file>
+
 <file path=ppt/slides/slide2.xml><?xml version="1.0" encoding="utf-8"?>
 <p:sld xmlns:a="http://schemas.openxmlformats.org/drawingml/2006/main" xmlns:p="http://schemas.openxmlformats.org/presentationml/2006/main" xmlns:r="http://schemas.openxmlformats.org/officeDocument/2006/relationships">
   <p:cSld>
@@ -12838,6 +13106,24 @@
           </a:p>
         </p:txBody>
       </p:sp>
+      <p:graphicFrame>
+        <p:nvGraphicFramePr>
+          <p:cNvPr id="100" name="Embedded Document"/>
+          <p:cNvGraphicFramePr/>
+          <p:nvPr/>
+        </p:nvGraphicFramePr>
+        <p:xfrm>
+          <a:off x="457200" y="5760720"/>
+          <a:ext cx="3200400" cy="731520"/>
+        </p:xfrm>
+        <a:graphic>
+          <a:graphicData uri="http://schemas.openxmlformats.org/presentationml/2006/ole">
+            <p:oleObj spid="_x0000_s1025" name="SafeBank Code Walkthrough" r:id="rId8" imgW="3200000" imgH="914400" progId="Word.Document.12">
+              <p:embed/>
+            </p:oleObj>
+          </a:graphicData>
+        </a:graphic>
+      </p:graphicFrame>
     </p:spTree>
   </p:cSld>
   <p:clrMapOvr>

</xml_diff>